<commit_message>
Upgrade to .NET 10 and replace Swagger with Scalar
- Target net10.0 in all projects; drop RollForward
- Replace Swashbuckle with built-in Microsoft.AspNetCore.OpenApi + Scalar
- Update test packages to current versions
- Update README, pseudocode, and architecture deck

Co-Authored-By: Claude Opus 5.5 <noreply@anthropic.com>
</commit_message>
<xml_diff>
--- a/docs/ChessEngineArchitecture.pptx
+++ b/docs/ChessEngineArchitecture.pptx
@@ -9093,7 +9093,7 @@
                 <a:ea typeface="Segoe UI" pitchFamily="34" charset="-122"/>
                 <a:cs typeface="Segoe UI" pitchFamily="34" charset="-120"/>
               </a:rPr>
-              <a:t>C# .NET 8 solution — four layers, clean separation</a:t>
+              <a:t>C# .NET 10 solution — four layers, clean separation</a:t>
             </a:r>
             <a:endParaRPr lang="en-US" sz="1300" dirty="0"/>
           </a:p>
@@ -9480,7 +9480,7 @@
                 <a:ea typeface="Segoe UI" pitchFamily="34" charset="-122"/>
                 <a:cs typeface="Segoe UI" pitchFamily="34" charset="-120"/>
               </a:rPr>
-              <a:t>(ASP.NET 8)</a:t>
+              <a:t>(ASP.NET 10)</a:t>
             </a:r>
             <a:endParaRPr lang="en-US" sz="1150" dirty="0"/>
           </a:p>

</xml_diff>